<commit_message>
I'm too tired for a coherent commit message
</commit_message>
<xml_diff>
--- a/ikar.pptx
+++ b/ikar.pptx
@@ -6,9 +6,6 @@
   </p:sldMasterIdLst>
   <p:sldIdLst>
     <p:sldId id="256" r:id="rId2"/>
-    <p:sldId id="257" r:id="rId3"/>
-    <p:sldId id="258" r:id="rId4"/>
-    <p:sldId id="259" r:id="rId5"/>
   </p:sldIdLst>
   <p:sldSz cx="12192000" cy="6858000"/>
   <p:notesSz cx="6858000" cy="9144000"/>
@@ -107,11 +104,6 @@
       </a:defRPr>
     </a:lvl9pPr>
   </p:defaultTextStyle>
-  <p:extLst>
-    <p:ext uri="{EFAFB233-063F-42B5-8137-9DF3F51BA10A}">
-      <p15:sldGuideLst xmlns:p15="http://schemas.microsoft.com/office/powerpoint/2012/main"/>
-    </p:ext>
-  </p:extLst>
 </p:presentation>
 </file>
 
@@ -262,7 +254,7 @@
           <a:p>
             <a:fld id="{534F590C-0178-477F-B62D-4BD2508A61A2}" type="datetimeFigureOut">
               <a:rPr lang="ru-RU" smtClean="0"/>
-              <a:t>19.11.2025</a:t>
+              <a:t>12.11.2025</a:t>
             </a:fld>
             <a:endParaRPr lang="ru-RU"/>
           </a:p>
@@ -460,7 +452,7 @@
           <a:p>
             <a:fld id="{534F590C-0178-477F-B62D-4BD2508A61A2}" type="datetimeFigureOut">
               <a:rPr lang="ru-RU" smtClean="0"/>
-              <a:t>19.11.2025</a:t>
+              <a:t>12.11.2025</a:t>
             </a:fld>
             <a:endParaRPr lang="ru-RU"/>
           </a:p>
@@ -668,7 +660,7 @@
           <a:p>
             <a:fld id="{534F590C-0178-477F-B62D-4BD2508A61A2}" type="datetimeFigureOut">
               <a:rPr lang="ru-RU" smtClean="0"/>
-              <a:t>19.11.2025</a:t>
+              <a:t>12.11.2025</a:t>
             </a:fld>
             <a:endParaRPr lang="ru-RU"/>
           </a:p>
@@ -866,7 +858,7 @@
           <a:p>
             <a:fld id="{534F590C-0178-477F-B62D-4BD2508A61A2}" type="datetimeFigureOut">
               <a:rPr lang="ru-RU" smtClean="0"/>
-              <a:t>19.11.2025</a:t>
+              <a:t>12.11.2025</a:t>
             </a:fld>
             <a:endParaRPr lang="ru-RU"/>
           </a:p>
@@ -1141,7 +1133,7 @@
           <a:p>
             <a:fld id="{534F590C-0178-477F-B62D-4BD2508A61A2}" type="datetimeFigureOut">
               <a:rPr lang="ru-RU" smtClean="0"/>
-              <a:t>19.11.2025</a:t>
+              <a:t>12.11.2025</a:t>
             </a:fld>
             <a:endParaRPr lang="ru-RU"/>
           </a:p>
@@ -1406,7 +1398,7 @@
           <a:p>
             <a:fld id="{534F590C-0178-477F-B62D-4BD2508A61A2}" type="datetimeFigureOut">
               <a:rPr lang="ru-RU" smtClean="0"/>
-              <a:t>19.11.2025</a:t>
+              <a:t>12.11.2025</a:t>
             </a:fld>
             <a:endParaRPr lang="ru-RU"/>
           </a:p>
@@ -1818,7 +1810,7 @@
           <a:p>
             <a:fld id="{534F590C-0178-477F-B62D-4BD2508A61A2}" type="datetimeFigureOut">
               <a:rPr lang="ru-RU" smtClean="0"/>
-              <a:t>19.11.2025</a:t>
+              <a:t>12.11.2025</a:t>
             </a:fld>
             <a:endParaRPr lang="ru-RU"/>
           </a:p>
@@ -1959,7 +1951,7 @@
           <a:p>
             <a:fld id="{534F590C-0178-477F-B62D-4BD2508A61A2}" type="datetimeFigureOut">
               <a:rPr lang="ru-RU" smtClean="0"/>
-              <a:t>19.11.2025</a:t>
+              <a:t>12.11.2025</a:t>
             </a:fld>
             <a:endParaRPr lang="ru-RU"/>
           </a:p>
@@ -2072,7 +2064,7 @@
           <a:p>
             <a:fld id="{534F590C-0178-477F-B62D-4BD2508A61A2}" type="datetimeFigureOut">
               <a:rPr lang="ru-RU" smtClean="0"/>
-              <a:t>19.11.2025</a:t>
+              <a:t>12.11.2025</a:t>
             </a:fld>
             <a:endParaRPr lang="ru-RU"/>
           </a:p>
@@ -2383,7 +2375,7 @@
           <a:p>
             <a:fld id="{534F590C-0178-477F-B62D-4BD2508A61A2}" type="datetimeFigureOut">
               <a:rPr lang="ru-RU" smtClean="0"/>
-              <a:t>19.11.2025</a:t>
+              <a:t>12.11.2025</a:t>
             </a:fld>
             <a:endParaRPr lang="ru-RU"/>
           </a:p>
@@ -2671,7 +2663,7 @@
           <a:p>
             <a:fld id="{534F590C-0178-477F-B62D-4BD2508A61A2}" type="datetimeFigureOut">
               <a:rPr lang="ru-RU" smtClean="0"/>
-              <a:t>19.11.2025</a:t>
+              <a:t>12.11.2025</a:t>
             </a:fld>
             <a:endParaRPr lang="ru-RU"/>
           </a:p>
@@ -2912,7 +2904,7 @@
           <a:p>
             <a:fld id="{534F590C-0178-477F-B62D-4BD2508A61A2}" type="datetimeFigureOut">
               <a:rPr lang="ru-RU" smtClean="0"/>
-              <a:t>19.11.2025</a:t>
+              <a:t>12.11.2025</a:t>
             </a:fld>
             <a:endParaRPr lang="ru-RU"/>
           </a:p>
@@ -3394,7 +3386,7 @@
         </p:spPr>
         <p:txBody>
           <a:bodyPr>
-            <a:normAutofit fontScale="92500" lnSpcReduction="20000"/>
+            <a:normAutofit fontScale="85000" lnSpcReduction="10000"/>
           </a:bodyPr>
           <a:lstStyle/>
           <a:p>
@@ -3402,29 +3394,12 @@
             <a:r>
               <a:rPr lang="ru-RU" sz="2800" i="1" dirty="0">
                 <a:effectLst/>
-                <a:latin typeface="Sitka Subheading" panose="02000505000000020004" pitchFamily="2" charset="0"/>
+                <a:latin typeface="Comic Sans MS" panose="030F0702030302020204" pitchFamily="66" charset="0"/>
               </a:rPr>
-              <a:t>Проект, направленный на </a:t>
-            </a:r>
-            <a:r>
-              <a:rPr lang="ru-RU" sz="2800" i="1" dirty="0">
-                <a:solidFill>
-                  <a:srgbClr val="FF0000"/>
-                </a:solidFill>
-                <a:effectLst/>
-                <a:latin typeface="Sitka Subheading" panose="02000505000000020004" pitchFamily="2" charset="0"/>
-              </a:rPr>
-              <a:t>оптимизацию</a:t>
-            </a:r>
-            <a:r>
-              <a:rPr lang="ru-RU" sz="2800" i="1" dirty="0">
-                <a:effectLst/>
-                <a:latin typeface="Sitka Subheading" panose="02000505000000020004" pitchFamily="2" charset="0"/>
-              </a:rPr>
-              <a:t> процесса создания сертификатов для больших групп людей за счет использования электронных таблиц Excel</a:t>
+              <a:t>Проект, направленный на оптимизацию процесса создания сертификатов для больших групп людей за счет использования электронных таблиц Excel</a:t>
             </a:r>
             <a:endParaRPr lang="ru-RU" sz="2800" i="1" dirty="0">
-              <a:latin typeface="Sitka Subheading" panose="02000505000000020004" pitchFamily="2" charset="0"/>
+              <a:latin typeface="Comic Sans MS" panose="030F0702030302020204" pitchFamily="66" charset="0"/>
             </a:endParaRPr>
           </a:p>
         </p:txBody>
@@ -3485,1398 +3460,18 @@
   <p:clrMapOvr>
     <a:masterClrMapping/>
   </p:clrMapOvr>
-  <mc:AlternateContent xmlns:mc="http://schemas.openxmlformats.org/markup-compatibility/2006" xmlns:p14="http://schemas.microsoft.com/office/powerpoint/2010/main">
-    <mc:Choice Requires="p14">
+  <mc:AlternateContent xmlns:mc="http://schemas.openxmlformats.org/markup-compatibility/2006">
+    <mc:Choice xmlns:p14="http://schemas.microsoft.com/office/powerpoint/2010/main" Requires="p14">
       <p:transition spd="slow" p14:dur="800">
         <p:circle/>
       </p:transition>
     </mc:Choice>
-    <mc:Fallback xmlns="">
+    <mc:Fallback>
       <p:transition spd="slow">
         <p:circle/>
       </p:transition>
     </mc:Fallback>
   </mc:AlternateContent>
-  <p:timing>
-    <p:tnLst>
-      <p:par>
-        <p:cTn id="1" dur="indefinite" restart="never" nodeType="tmRoot">
-          <p:childTnLst>
-            <p:seq concurrent="1" nextAc="seek">
-              <p:cTn id="2" dur="indefinite" nodeType="mainSeq">
-                <p:childTnLst>
-                  <p:par>
-                    <p:cTn id="3" fill="hold">
-                      <p:stCondLst>
-                        <p:cond delay="indefinite"/>
-                      </p:stCondLst>
-                      <p:childTnLst>
-                        <p:par>
-                          <p:cTn id="4" fill="hold">
-                            <p:stCondLst>
-                              <p:cond delay="0"/>
-                            </p:stCondLst>
-                            <p:childTnLst>
-                              <p:par>
-                                <p:cTn id="5" presetID="42" presetClass="entr" presetSubtype="0" fill="hold" nodeType="clickEffect">
-                                  <p:stCondLst>
-                                    <p:cond delay="0"/>
-                                  </p:stCondLst>
-                                  <p:childTnLst>
-                                    <p:set>
-                                      <p:cBhvr>
-                                        <p:cTn id="6" dur="1" fill="hold">
-                                          <p:stCondLst>
-                                            <p:cond delay="0"/>
-                                          </p:stCondLst>
-                                        </p:cTn>
-                                        <p:tgtEl>
-                                          <p:spTgt spid="5"/>
-                                        </p:tgtEl>
-                                        <p:attrNameLst>
-                                          <p:attrName>style.visibility</p:attrName>
-                                        </p:attrNameLst>
-                                      </p:cBhvr>
-                                      <p:to>
-                                        <p:strVal val="visible"/>
-                                      </p:to>
-                                    </p:set>
-                                    <p:animEffect transition="in" filter="fade">
-                                      <p:cBhvr>
-                                        <p:cTn id="7" dur="1000"/>
-                                        <p:tgtEl>
-                                          <p:spTgt spid="5"/>
-                                        </p:tgtEl>
-                                      </p:cBhvr>
-                                    </p:animEffect>
-                                    <p:anim calcmode="lin" valueType="num">
-                                      <p:cBhvr>
-                                        <p:cTn id="8" dur="1000" fill="hold"/>
-                                        <p:tgtEl>
-                                          <p:spTgt spid="5"/>
-                                        </p:tgtEl>
-                                        <p:attrNameLst>
-                                          <p:attrName>ppt_x</p:attrName>
-                                        </p:attrNameLst>
-                                      </p:cBhvr>
-                                      <p:tavLst>
-                                        <p:tav tm="0">
-                                          <p:val>
-                                            <p:strVal val="#ppt_x"/>
-                                          </p:val>
-                                        </p:tav>
-                                        <p:tav tm="100000">
-                                          <p:val>
-                                            <p:strVal val="#ppt_x"/>
-                                          </p:val>
-                                        </p:tav>
-                                      </p:tavLst>
-                                    </p:anim>
-                                    <p:anim calcmode="lin" valueType="num">
-                                      <p:cBhvr>
-                                        <p:cTn id="9" dur="1000" fill="hold"/>
-                                        <p:tgtEl>
-                                          <p:spTgt spid="5"/>
-                                        </p:tgtEl>
-                                        <p:attrNameLst>
-                                          <p:attrName>ppt_y</p:attrName>
-                                        </p:attrNameLst>
-                                      </p:cBhvr>
-                                      <p:tavLst>
-                                        <p:tav tm="0">
-                                          <p:val>
-                                            <p:strVal val="#ppt_y+.1"/>
-                                          </p:val>
-                                        </p:tav>
-                                        <p:tav tm="100000">
-                                          <p:val>
-                                            <p:strVal val="#ppt_y"/>
-                                          </p:val>
-                                        </p:tav>
-                                      </p:tavLst>
-                                    </p:anim>
-                                  </p:childTnLst>
-                                </p:cTn>
-                              </p:par>
-                            </p:childTnLst>
-                          </p:cTn>
-                        </p:par>
-                      </p:childTnLst>
-                    </p:cTn>
-                  </p:par>
-                </p:childTnLst>
-              </p:cTn>
-              <p:prevCondLst>
-                <p:cond evt="onPrev" delay="0">
-                  <p:tgtEl>
-                    <p:sldTgt/>
-                  </p:tgtEl>
-                </p:cond>
-              </p:prevCondLst>
-              <p:nextCondLst>
-                <p:cond evt="onNext" delay="0">
-                  <p:tgtEl>
-                    <p:sldTgt/>
-                  </p:tgtEl>
-                </p:cond>
-              </p:nextCondLst>
-            </p:seq>
-          </p:childTnLst>
-        </p:cTn>
-      </p:par>
-    </p:tnLst>
-  </p:timing>
-</p:sld>
-</file>
-
-<file path=ppt/slides/slide2.xml><?xml version="1.0" encoding="utf-8"?>
-<p:sld xmlns:a="http://schemas.openxmlformats.org/drawingml/2006/main" xmlns:r="http://schemas.openxmlformats.org/officeDocument/2006/relationships" xmlns:p="http://schemas.openxmlformats.org/presentationml/2006/main">
-  <p:cSld>
-    <p:spTree>
-      <p:nvGrpSpPr>
-        <p:cNvPr id="1" name=""/>
-        <p:cNvGrpSpPr/>
-        <p:nvPr/>
-      </p:nvGrpSpPr>
-      <p:grpSpPr>
-        <a:xfrm>
-          <a:off x="0" y="0"/>
-          <a:ext cx="0" cy="0"/>
-          <a:chOff x="0" y="0"/>
-          <a:chExt cx="0" cy="0"/>
-        </a:xfrm>
-      </p:grpSpPr>
-      <p:sp>
-        <p:nvSpPr>
-          <p:cNvPr id="2" name="Заголовок 1">
-            <a:extLst>
-              <a:ext uri="{FF2B5EF4-FFF2-40B4-BE49-F238E27FC236}">
-                <a16:creationId xmlns:a16="http://schemas.microsoft.com/office/drawing/2014/main" id="{4EC1D106-3230-4BA9-89CC-4E800368291B}"/>
-              </a:ext>
-            </a:extLst>
-          </p:cNvPr>
-          <p:cNvSpPr>
-            <a:spLocks noGrp="1"/>
-          </p:cNvSpPr>
-          <p:nvPr>
-            <p:ph type="title"/>
-          </p:nvPr>
-        </p:nvSpPr>
-        <p:spPr/>
-        <p:txBody>
-          <a:bodyPr/>
-          <a:lstStyle/>
-          <a:p>
-            <a:r>
-              <a:rPr lang="ru-RU" b="1" dirty="0">
-                <a:latin typeface="Sitka Subheading" panose="02000505000000020004" pitchFamily="2" charset="0"/>
-              </a:rPr>
-              <a:t>Цели проекта:</a:t>
-            </a:r>
-          </a:p>
-        </p:txBody>
-      </p:sp>
-      <p:sp>
-        <p:nvSpPr>
-          <p:cNvPr id="3" name="Объект 2">
-            <a:extLst>
-              <a:ext uri="{FF2B5EF4-FFF2-40B4-BE49-F238E27FC236}">
-                <a16:creationId xmlns:a16="http://schemas.microsoft.com/office/drawing/2014/main" id="{4A8CFEA6-0107-4D72-A221-CC3DA2CF79FD}"/>
-              </a:ext>
-            </a:extLst>
-          </p:cNvPr>
-          <p:cNvSpPr>
-            <a:spLocks noGrp="1"/>
-          </p:cNvSpPr>
-          <p:nvPr>
-            <p:ph idx="1"/>
-          </p:nvPr>
-        </p:nvSpPr>
-        <p:spPr>
-          <a:xfrm>
-            <a:off x="838200" y="1825625"/>
-            <a:ext cx="10515600" cy="1860255"/>
-          </a:xfrm>
-        </p:spPr>
-        <p:txBody>
-          <a:bodyPr>
-            <a:normAutofit fontScale="92500" lnSpcReduction="10000"/>
-          </a:bodyPr>
-          <a:lstStyle/>
-          <a:p>
-            <a:pPr marL="514350" indent="-514350" algn="just">
-              <a:buAutoNum type="arabicPeriod"/>
-            </a:pPr>
-            <a:r>
-              <a:rPr lang="ru-RU" dirty="0">
-                <a:latin typeface="Sitka Subheading" panose="02000505000000020004" pitchFamily="2" charset="0"/>
-                <a:ea typeface="Ebrima" panose="02000000000000000000" pitchFamily="2" charset="0"/>
-                <a:cs typeface="Ebrima" panose="02000000000000000000" pitchFamily="2" charset="0"/>
-              </a:rPr>
-              <a:t>Проект создан для </a:t>
-            </a:r>
-            <a:r>
-              <a:rPr lang="ru-RU" dirty="0">
-                <a:solidFill>
-                  <a:srgbClr val="FF0000"/>
-                </a:solidFill>
-                <a:latin typeface="Sitka Subheading" panose="02000505000000020004" pitchFamily="2" charset="0"/>
-                <a:ea typeface="Ebrima" panose="02000000000000000000" pitchFamily="2" charset="0"/>
-                <a:cs typeface="Ebrima" panose="02000000000000000000" pitchFamily="2" charset="0"/>
-              </a:rPr>
-              <a:t>упрощения</a:t>
-            </a:r>
-            <a:r>
-              <a:rPr lang="ru-RU" dirty="0">
-                <a:latin typeface="Sitka Subheading" panose="02000505000000020004" pitchFamily="2" charset="0"/>
-                <a:ea typeface="Ebrima" panose="02000000000000000000" pitchFamily="2" charset="0"/>
-                <a:cs typeface="Ebrima" panose="02000000000000000000" pitchFamily="2" charset="0"/>
-              </a:rPr>
-              <a:t> создания дипломов, грамот и т.п.</a:t>
-            </a:r>
-          </a:p>
-          <a:p>
-            <a:pPr marL="514350" indent="-514350" algn="just">
-              <a:buAutoNum type="arabicPeriod"/>
-            </a:pPr>
-            <a:endParaRPr lang="ru-RU" dirty="0">
-              <a:latin typeface="Sitka Subheading" panose="02000505000000020004" pitchFamily="2" charset="0"/>
-              <a:ea typeface="Ebrima" panose="02000000000000000000" pitchFamily="2" charset="0"/>
-              <a:cs typeface="Ebrima" panose="02000000000000000000" pitchFamily="2" charset="0"/>
-            </a:endParaRPr>
-          </a:p>
-          <a:p>
-            <a:pPr marL="514350" indent="-514350" algn="just">
-              <a:spcBef>
-                <a:spcPts val="0"/>
-              </a:spcBef>
-              <a:buAutoNum type="arabicPeriod"/>
-            </a:pPr>
-            <a:r>
-              <a:rPr lang="ru-RU" sz="3000" dirty="0">
-                <a:latin typeface="Sitka Subheading" panose="02000505000000020004" pitchFamily="2" charset="0"/>
-                <a:ea typeface="Ebrima" panose="02000000000000000000" pitchFamily="2" charset="0"/>
-                <a:cs typeface="Ebrima" panose="02000000000000000000" pitchFamily="2" charset="0"/>
-              </a:rPr>
-              <a:t>Также</a:t>
-            </a:r>
-            <a:r>
-              <a:rPr lang="ru-RU" dirty="0">
-                <a:latin typeface="Sitka Subheading" panose="02000505000000020004" pitchFamily="2" charset="0"/>
-                <a:ea typeface="Ebrima" panose="02000000000000000000" pitchFamily="2" charset="0"/>
-                <a:cs typeface="Ebrima" panose="02000000000000000000" pitchFamily="2" charset="0"/>
-              </a:rPr>
-              <a:t> с помощью этого проекта можно </a:t>
-            </a:r>
-            <a:r>
-              <a:rPr lang="ru-RU" dirty="0">
-                <a:solidFill>
-                  <a:srgbClr val="FF0000"/>
-                </a:solidFill>
-                <a:latin typeface="Sitka Subheading" panose="02000505000000020004" pitchFamily="2" charset="0"/>
-                <a:ea typeface="Ebrima" panose="02000000000000000000" pitchFamily="2" charset="0"/>
-                <a:cs typeface="Ebrima" panose="02000000000000000000" pitchFamily="2" charset="0"/>
-              </a:rPr>
-              <a:t>сэкономить время </a:t>
-            </a:r>
-            <a:r>
-              <a:rPr lang="ru-RU" dirty="0">
-                <a:latin typeface="Sitka Subheading" panose="02000505000000020004" pitchFamily="2" charset="0"/>
-                <a:ea typeface="Ebrima" panose="02000000000000000000" pitchFamily="2" charset="0"/>
-                <a:cs typeface="Ebrima" panose="02000000000000000000" pitchFamily="2" charset="0"/>
-              </a:rPr>
-              <a:t>на распечатку кучи документов по типу грамот.</a:t>
-            </a:r>
-          </a:p>
-        </p:txBody>
-      </p:sp>
-    </p:spTree>
-    <p:extLst>
-      <p:ext uri="{BB962C8B-B14F-4D97-AF65-F5344CB8AC3E}">
-        <p14:creationId xmlns:p14="http://schemas.microsoft.com/office/powerpoint/2010/main" val="2452037760"/>
-      </p:ext>
-    </p:extLst>
-  </p:cSld>
-  <p:clrMapOvr>
-    <a:masterClrMapping/>
-  </p:clrMapOvr>
-  <p:timing>
-    <p:tnLst>
-      <p:par>
-        <p:cTn id="1" dur="indefinite" restart="never" nodeType="tmRoot">
-          <p:childTnLst>
-            <p:seq concurrent="1" nextAc="seek">
-              <p:cTn id="2" dur="indefinite" nodeType="mainSeq">
-                <p:childTnLst>
-                  <p:par>
-                    <p:cTn id="3" fill="hold">
-                      <p:stCondLst>
-                        <p:cond delay="indefinite"/>
-                      </p:stCondLst>
-                      <p:childTnLst>
-                        <p:par>
-                          <p:cTn id="4" fill="hold">
-                            <p:stCondLst>
-                              <p:cond delay="0"/>
-                            </p:stCondLst>
-                            <p:childTnLst>
-                              <p:par>
-                                <p:cTn id="5" presetID="26" presetClass="entr" presetSubtype="0" fill="hold" nodeType="clickEffect">
-                                  <p:stCondLst>
-                                    <p:cond delay="0"/>
-                                  </p:stCondLst>
-                                  <p:childTnLst>
-                                    <p:set>
-                                      <p:cBhvr>
-                                        <p:cTn id="6" dur="1" fill="hold">
-                                          <p:stCondLst>
-                                            <p:cond delay="0"/>
-                                          </p:stCondLst>
-                                        </p:cTn>
-                                        <p:tgtEl>
-                                          <p:spTgt spid="3">
-                                            <p:txEl>
-                                              <p:pRg st="0" end="0"/>
-                                            </p:txEl>
-                                          </p:spTgt>
-                                        </p:tgtEl>
-                                        <p:attrNameLst>
-                                          <p:attrName>style.visibility</p:attrName>
-                                        </p:attrNameLst>
-                                      </p:cBhvr>
-                                      <p:to>
-                                        <p:strVal val="visible"/>
-                                      </p:to>
-                                    </p:set>
-                                    <p:animEffect transition="in" filter="wipe(down)">
-                                      <p:cBhvr>
-                                        <p:cTn id="7" dur="580">
-                                          <p:stCondLst>
-                                            <p:cond delay="0"/>
-                                          </p:stCondLst>
-                                        </p:cTn>
-                                        <p:tgtEl>
-                                          <p:spTgt spid="3">
-                                            <p:txEl>
-                                              <p:pRg st="0" end="0"/>
-                                            </p:txEl>
-                                          </p:spTgt>
-                                        </p:tgtEl>
-                                      </p:cBhvr>
-                                    </p:animEffect>
-                                    <p:anim calcmode="lin" valueType="num">
-                                      <p:cBhvr>
-                                        <p:cTn id="8" dur="1822" tmFilter="0,0; 0.14,0.36; 0.43,0.73; 0.71,0.91; 1.0,1.0">
-                                          <p:stCondLst>
-                                            <p:cond delay="0"/>
-                                          </p:stCondLst>
-                                        </p:cTn>
-                                        <p:tgtEl>
-                                          <p:spTgt spid="3">
-                                            <p:txEl>
-                                              <p:pRg st="0" end="0"/>
-                                            </p:txEl>
-                                          </p:spTgt>
-                                        </p:tgtEl>
-                                        <p:attrNameLst>
-                                          <p:attrName>ppt_x</p:attrName>
-                                        </p:attrNameLst>
-                                      </p:cBhvr>
-                                      <p:tavLst>
-                                        <p:tav tm="0">
-                                          <p:val>
-                                            <p:strVal val="#ppt_x-0.25"/>
-                                          </p:val>
-                                        </p:tav>
-                                        <p:tav tm="100000">
-                                          <p:val>
-                                            <p:strVal val="#ppt_x"/>
-                                          </p:val>
-                                        </p:tav>
-                                      </p:tavLst>
-                                    </p:anim>
-                                    <p:anim calcmode="lin" valueType="num">
-                                      <p:cBhvr>
-                                        <p:cTn id="9" dur="664" tmFilter="0.0,0.0; 0.25,0.07; 0.50,0.2; 0.75,0.467; 1.0,1.0">
-                                          <p:stCondLst>
-                                            <p:cond delay="0"/>
-                                          </p:stCondLst>
-                                        </p:cTn>
-                                        <p:tgtEl>
-                                          <p:spTgt spid="3">
-                                            <p:txEl>
-                                              <p:pRg st="0" end="0"/>
-                                            </p:txEl>
-                                          </p:spTgt>
-                                        </p:tgtEl>
-                                        <p:attrNameLst>
-                                          <p:attrName>ppt_y</p:attrName>
-                                        </p:attrNameLst>
-                                      </p:cBhvr>
-                                      <p:tavLst>
-                                        <p:tav tm="0" fmla="#ppt_y-sin(pi*$)/3">
-                                          <p:val>
-                                            <p:fltVal val="0.5"/>
-                                          </p:val>
-                                        </p:tav>
-                                        <p:tav tm="100000">
-                                          <p:val>
-                                            <p:fltVal val="1"/>
-                                          </p:val>
-                                        </p:tav>
-                                      </p:tavLst>
-                                    </p:anim>
-                                    <p:anim calcmode="lin" valueType="num">
-                                      <p:cBhvr>
-                                        <p:cTn id="10" dur="664" tmFilter="0, 0; 0.125,0.2665; 0.25,0.4; 0.375,0.465; 0.5,0.5;  0.625,0.535; 0.75,0.6; 0.875,0.7335; 1,1">
-                                          <p:stCondLst>
-                                            <p:cond delay="664"/>
-                                          </p:stCondLst>
-                                        </p:cTn>
-                                        <p:tgtEl>
-                                          <p:spTgt spid="3">
-                                            <p:txEl>
-                                              <p:pRg st="0" end="0"/>
-                                            </p:txEl>
-                                          </p:spTgt>
-                                        </p:tgtEl>
-                                        <p:attrNameLst>
-                                          <p:attrName>ppt_y</p:attrName>
-                                        </p:attrNameLst>
-                                      </p:cBhvr>
-                                      <p:tavLst>
-                                        <p:tav tm="0" fmla="#ppt_y-sin(pi*$)/9">
-                                          <p:val>
-                                            <p:fltVal val="0"/>
-                                          </p:val>
-                                        </p:tav>
-                                        <p:tav tm="100000">
-                                          <p:val>
-                                            <p:fltVal val="1"/>
-                                          </p:val>
-                                        </p:tav>
-                                      </p:tavLst>
-                                    </p:anim>
-                                    <p:anim calcmode="lin" valueType="num">
-                                      <p:cBhvr>
-                                        <p:cTn id="11" dur="332" tmFilter="0, 0; 0.125,0.2665; 0.25,0.4; 0.375,0.465; 0.5,0.5;  0.625,0.535; 0.75,0.6; 0.875,0.7335; 1,1">
-                                          <p:stCondLst>
-                                            <p:cond delay="1324"/>
-                                          </p:stCondLst>
-                                        </p:cTn>
-                                        <p:tgtEl>
-                                          <p:spTgt spid="3">
-                                            <p:txEl>
-                                              <p:pRg st="0" end="0"/>
-                                            </p:txEl>
-                                          </p:spTgt>
-                                        </p:tgtEl>
-                                        <p:attrNameLst>
-                                          <p:attrName>ppt_y</p:attrName>
-                                        </p:attrNameLst>
-                                      </p:cBhvr>
-                                      <p:tavLst>
-                                        <p:tav tm="0" fmla="#ppt_y-sin(pi*$)/27">
-                                          <p:val>
-                                            <p:fltVal val="0"/>
-                                          </p:val>
-                                        </p:tav>
-                                        <p:tav tm="100000">
-                                          <p:val>
-                                            <p:fltVal val="1"/>
-                                          </p:val>
-                                        </p:tav>
-                                      </p:tavLst>
-                                    </p:anim>
-                                    <p:anim calcmode="lin" valueType="num">
-                                      <p:cBhvr>
-                                        <p:cTn id="12" dur="164" tmFilter="0, 0; 0.125,0.2665; 0.25,0.4; 0.375,0.465; 0.5,0.5;  0.625,0.535; 0.75,0.6; 0.875,0.7335; 1,1">
-                                          <p:stCondLst>
-                                            <p:cond delay="1656"/>
-                                          </p:stCondLst>
-                                        </p:cTn>
-                                        <p:tgtEl>
-                                          <p:spTgt spid="3">
-                                            <p:txEl>
-                                              <p:pRg st="0" end="0"/>
-                                            </p:txEl>
-                                          </p:spTgt>
-                                        </p:tgtEl>
-                                        <p:attrNameLst>
-                                          <p:attrName>ppt_y</p:attrName>
-                                        </p:attrNameLst>
-                                      </p:cBhvr>
-                                      <p:tavLst>
-                                        <p:tav tm="0" fmla="#ppt_y-sin(pi*$)/81">
-                                          <p:val>
-                                            <p:fltVal val="0"/>
-                                          </p:val>
-                                        </p:tav>
-                                        <p:tav tm="100000">
-                                          <p:val>
-                                            <p:fltVal val="1"/>
-                                          </p:val>
-                                        </p:tav>
-                                      </p:tavLst>
-                                    </p:anim>
-                                    <p:animScale>
-                                      <p:cBhvr>
-                                        <p:cTn id="13" dur="26">
-                                          <p:stCondLst>
-                                            <p:cond delay="650"/>
-                                          </p:stCondLst>
-                                        </p:cTn>
-                                        <p:tgtEl>
-                                          <p:spTgt spid="3">
-                                            <p:txEl>
-                                              <p:pRg st="0" end="0"/>
-                                            </p:txEl>
-                                          </p:spTgt>
-                                        </p:tgtEl>
-                                      </p:cBhvr>
-                                      <p:to x="100000" y="60000"/>
-                                    </p:animScale>
-                                    <p:animScale>
-                                      <p:cBhvr>
-                                        <p:cTn id="14" dur="166" decel="50000">
-                                          <p:stCondLst>
-                                            <p:cond delay="676"/>
-                                          </p:stCondLst>
-                                        </p:cTn>
-                                        <p:tgtEl>
-                                          <p:spTgt spid="3">
-                                            <p:txEl>
-                                              <p:pRg st="0" end="0"/>
-                                            </p:txEl>
-                                          </p:spTgt>
-                                        </p:tgtEl>
-                                      </p:cBhvr>
-                                      <p:to x="100000" y="100000"/>
-                                    </p:animScale>
-                                    <p:animScale>
-                                      <p:cBhvr>
-                                        <p:cTn id="15" dur="26">
-                                          <p:stCondLst>
-                                            <p:cond delay="1312"/>
-                                          </p:stCondLst>
-                                        </p:cTn>
-                                        <p:tgtEl>
-                                          <p:spTgt spid="3">
-                                            <p:txEl>
-                                              <p:pRg st="0" end="0"/>
-                                            </p:txEl>
-                                          </p:spTgt>
-                                        </p:tgtEl>
-                                      </p:cBhvr>
-                                      <p:to x="100000" y="80000"/>
-                                    </p:animScale>
-                                    <p:animScale>
-                                      <p:cBhvr>
-                                        <p:cTn id="16" dur="166" decel="50000">
-                                          <p:stCondLst>
-                                            <p:cond delay="1338"/>
-                                          </p:stCondLst>
-                                        </p:cTn>
-                                        <p:tgtEl>
-                                          <p:spTgt spid="3">
-                                            <p:txEl>
-                                              <p:pRg st="0" end="0"/>
-                                            </p:txEl>
-                                          </p:spTgt>
-                                        </p:tgtEl>
-                                      </p:cBhvr>
-                                      <p:to x="100000" y="100000"/>
-                                    </p:animScale>
-                                    <p:animScale>
-                                      <p:cBhvr>
-                                        <p:cTn id="17" dur="26">
-                                          <p:stCondLst>
-                                            <p:cond delay="1642"/>
-                                          </p:stCondLst>
-                                        </p:cTn>
-                                        <p:tgtEl>
-                                          <p:spTgt spid="3">
-                                            <p:txEl>
-                                              <p:pRg st="0" end="0"/>
-                                            </p:txEl>
-                                          </p:spTgt>
-                                        </p:tgtEl>
-                                      </p:cBhvr>
-                                      <p:to x="100000" y="90000"/>
-                                    </p:animScale>
-                                    <p:animScale>
-                                      <p:cBhvr>
-                                        <p:cTn id="18" dur="166" decel="50000">
-                                          <p:stCondLst>
-                                            <p:cond delay="1668"/>
-                                          </p:stCondLst>
-                                        </p:cTn>
-                                        <p:tgtEl>
-                                          <p:spTgt spid="3">
-                                            <p:txEl>
-                                              <p:pRg st="0" end="0"/>
-                                            </p:txEl>
-                                          </p:spTgt>
-                                        </p:tgtEl>
-                                      </p:cBhvr>
-                                      <p:to x="100000" y="100000"/>
-                                    </p:animScale>
-                                    <p:animScale>
-                                      <p:cBhvr>
-                                        <p:cTn id="19" dur="26">
-                                          <p:stCondLst>
-                                            <p:cond delay="1808"/>
-                                          </p:stCondLst>
-                                        </p:cTn>
-                                        <p:tgtEl>
-                                          <p:spTgt spid="3">
-                                            <p:txEl>
-                                              <p:pRg st="0" end="0"/>
-                                            </p:txEl>
-                                          </p:spTgt>
-                                        </p:tgtEl>
-                                      </p:cBhvr>
-                                      <p:to x="100000" y="95000"/>
-                                    </p:animScale>
-                                    <p:animScale>
-                                      <p:cBhvr>
-                                        <p:cTn id="20" dur="166" decel="50000">
-                                          <p:stCondLst>
-                                            <p:cond delay="1834"/>
-                                          </p:stCondLst>
-                                        </p:cTn>
-                                        <p:tgtEl>
-                                          <p:spTgt spid="3">
-                                            <p:txEl>
-                                              <p:pRg st="0" end="0"/>
-                                            </p:txEl>
-                                          </p:spTgt>
-                                        </p:tgtEl>
-                                      </p:cBhvr>
-                                      <p:to x="100000" y="100000"/>
-                                    </p:animScale>
-                                  </p:childTnLst>
-                                </p:cTn>
-                              </p:par>
-                            </p:childTnLst>
-                          </p:cTn>
-                        </p:par>
-                      </p:childTnLst>
-                    </p:cTn>
-                  </p:par>
-                  <p:par>
-                    <p:cTn id="21" fill="hold">
-                      <p:stCondLst>
-                        <p:cond delay="indefinite"/>
-                      </p:stCondLst>
-                      <p:childTnLst>
-                        <p:par>
-                          <p:cTn id="22" fill="hold">
-                            <p:stCondLst>
-                              <p:cond delay="0"/>
-                            </p:stCondLst>
-                            <p:childTnLst>
-                              <p:par>
-                                <p:cTn id="23" presetID="26" presetClass="entr" presetSubtype="0" fill="hold" nodeType="clickEffect">
-                                  <p:stCondLst>
-                                    <p:cond delay="0"/>
-                                  </p:stCondLst>
-                                  <p:childTnLst>
-                                    <p:set>
-                                      <p:cBhvr>
-                                        <p:cTn id="24" dur="1" fill="hold">
-                                          <p:stCondLst>
-                                            <p:cond delay="0"/>
-                                          </p:stCondLst>
-                                        </p:cTn>
-                                        <p:tgtEl>
-                                          <p:spTgt spid="3">
-                                            <p:txEl>
-                                              <p:pRg st="2" end="2"/>
-                                            </p:txEl>
-                                          </p:spTgt>
-                                        </p:tgtEl>
-                                        <p:attrNameLst>
-                                          <p:attrName>style.visibility</p:attrName>
-                                        </p:attrNameLst>
-                                      </p:cBhvr>
-                                      <p:to>
-                                        <p:strVal val="visible"/>
-                                      </p:to>
-                                    </p:set>
-                                    <p:animEffect transition="in" filter="wipe(down)">
-                                      <p:cBhvr>
-                                        <p:cTn id="25" dur="580">
-                                          <p:stCondLst>
-                                            <p:cond delay="0"/>
-                                          </p:stCondLst>
-                                        </p:cTn>
-                                        <p:tgtEl>
-                                          <p:spTgt spid="3">
-                                            <p:txEl>
-                                              <p:pRg st="2" end="2"/>
-                                            </p:txEl>
-                                          </p:spTgt>
-                                        </p:tgtEl>
-                                      </p:cBhvr>
-                                    </p:animEffect>
-                                    <p:anim calcmode="lin" valueType="num">
-                                      <p:cBhvr>
-                                        <p:cTn id="26" dur="1822" tmFilter="0,0; 0.14,0.36; 0.43,0.73; 0.71,0.91; 1.0,1.0">
-                                          <p:stCondLst>
-                                            <p:cond delay="0"/>
-                                          </p:stCondLst>
-                                        </p:cTn>
-                                        <p:tgtEl>
-                                          <p:spTgt spid="3">
-                                            <p:txEl>
-                                              <p:pRg st="2" end="2"/>
-                                            </p:txEl>
-                                          </p:spTgt>
-                                        </p:tgtEl>
-                                        <p:attrNameLst>
-                                          <p:attrName>ppt_x</p:attrName>
-                                        </p:attrNameLst>
-                                      </p:cBhvr>
-                                      <p:tavLst>
-                                        <p:tav tm="0">
-                                          <p:val>
-                                            <p:strVal val="#ppt_x-0.25"/>
-                                          </p:val>
-                                        </p:tav>
-                                        <p:tav tm="100000">
-                                          <p:val>
-                                            <p:strVal val="#ppt_x"/>
-                                          </p:val>
-                                        </p:tav>
-                                      </p:tavLst>
-                                    </p:anim>
-                                    <p:anim calcmode="lin" valueType="num">
-                                      <p:cBhvr>
-                                        <p:cTn id="27" dur="664" tmFilter="0.0,0.0; 0.25,0.07; 0.50,0.2; 0.75,0.467; 1.0,1.0">
-                                          <p:stCondLst>
-                                            <p:cond delay="0"/>
-                                          </p:stCondLst>
-                                        </p:cTn>
-                                        <p:tgtEl>
-                                          <p:spTgt spid="3">
-                                            <p:txEl>
-                                              <p:pRg st="2" end="2"/>
-                                            </p:txEl>
-                                          </p:spTgt>
-                                        </p:tgtEl>
-                                        <p:attrNameLst>
-                                          <p:attrName>ppt_y</p:attrName>
-                                        </p:attrNameLst>
-                                      </p:cBhvr>
-                                      <p:tavLst>
-                                        <p:tav tm="0" fmla="#ppt_y-sin(pi*$)/3">
-                                          <p:val>
-                                            <p:fltVal val="0.5"/>
-                                          </p:val>
-                                        </p:tav>
-                                        <p:tav tm="100000">
-                                          <p:val>
-                                            <p:fltVal val="1"/>
-                                          </p:val>
-                                        </p:tav>
-                                      </p:tavLst>
-                                    </p:anim>
-                                    <p:anim calcmode="lin" valueType="num">
-                                      <p:cBhvr>
-                                        <p:cTn id="28" dur="664" tmFilter="0, 0; 0.125,0.2665; 0.25,0.4; 0.375,0.465; 0.5,0.5;  0.625,0.535; 0.75,0.6; 0.875,0.7335; 1,1">
-                                          <p:stCondLst>
-                                            <p:cond delay="664"/>
-                                          </p:stCondLst>
-                                        </p:cTn>
-                                        <p:tgtEl>
-                                          <p:spTgt spid="3">
-                                            <p:txEl>
-                                              <p:pRg st="2" end="2"/>
-                                            </p:txEl>
-                                          </p:spTgt>
-                                        </p:tgtEl>
-                                        <p:attrNameLst>
-                                          <p:attrName>ppt_y</p:attrName>
-                                        </p:attrNameLst>
-                                      </p:cBhvr>
-                                      <p:tavLst>
-                                        <p:tav tm="0" fmla="#ppt_y-sin(pi*$)/9">
-                                          <p:val>
-                                            <p:fltVal val="0"/>
-                                          </p:val>
-                                        </p:tav>
-                                        <p:tav tm="100000">
-                                          <p:val>
-                                            <p:fltVal val="1"/>
-                                          </p:val>
-                                        </p:tav>
-                                      </p:tavLst>
-                                    </p:anim>
-                                    <p:anim calcmode="lin" valueType="num">
-                                      <p:cBhvr>
-                                        <p:cTn id="29" dur="332" tmFilter="0, 0; 0.125,0.2665; 0.25,0.4; 0.375,0.465; 0.5,0.5;  0.625,0.535; 0.75,0.6; 0.875,0.7335; 1,1">
-                                          <p:stCondLst>
-                                            <p:cond delay="1324"/>
-                                          </p:stCondLst>
-                                        </p:cTn>
-                                        <p:tgtEl>
-                                          <p:spTgt spid="3">
-                                            <p:txEl>
-                                              <p:pRg st="2" end="2"/>
-                                            </p:txEl>
-                                          </p:spTgt>
-                                        </p:tgtEl>
-                                        <p:attrNameLst>
-                                          <p:attrName>ppt_y</p:attrName>
-                                        </p:attrNameLst>
-                                      </p:cBhvr>
-                                      <p:tavLst>
-                                        <p:tav tm="0" fmla="#ppt_y-sin(pi*$)/27">
-                                          <p:val>
-                                            <p:fltVal val="0"/>
-                                          </p:val>
-                                        </p:tav>
-                                        <p:tav tm="100000">
-                                          <p:val>
-                                            <p:fltVal val="1"/>
-                                          </p:val>
-                                        </p:tav>
-                                      </p:tavLst>
-                                    </p:anim>
-                                    <p:anim calcmode="lin" valueType="num">
-                                      <p:cBhvr>
-                                        <p:cTn id="30" dur="164" tmFilter="0, 0; 0.125,0.2665; 0.25,0.4; 0.375,0.465; 0.5,0.5;  0.625,0.535; 0.75,0.6; 0.875,0.7335; 1,1">
-                                          <p:stCondLst>
-                                            <p:cond delay="1656"/>
-                                          </p:stCondLst>
-                                        </p:cTn>
-                                        <p:tgtEl>
-                                          <p:spTgt spid="3">
-                                            <p:txEl>
-                                              <p:pRg st="2" end="2"/>
-                                            </p:txEl>
-                                          </p:spTgt>
-                                        </p:tgtEl>
-                                        <p:attrNameLst>
-                                          <p:attrName>ppt_y</p:attrName>
-                                        </p:attrNameLst>
-                                      </p:cBhvr>
-                                      <p:tavLst>
-                                        <p:tav tm="0" fmla="#ppt_y-sin(pi*$)/81">
-                                          <p:val>
-                                            <p:fltVal val="0"/>
-                                          </p:val>
-                                        </p:tav>
-                                        <p:tav tm="100000">
-                                          <p:val>
-                                            <p:fltVal val="1"/>
-                                          </p:val>
-                                        </p:tav>
-                                      </p:tavLst>
-                                    </p:anim>
-                                    <p:animScale>
-                                      <p:cBhvr>
-                                        <p:cTn id="31" dur="26">
-                                          <p:stCondLst>
-                                            <p:cond delay="650"/>
-                                          </p:stCondLst>
-                                        </p:cTn>
-                                        <p:tgtEl>
-                                          <p:spTgt spid="3">
-                                            <p:txEl>
-                                              <p:pRg st="2" end="2"/>
-                                            </p:txEl>
-                                          </p:spTgt>
-                                        </p:tgtEl>
-                                      </p:cBhvr>
-                                      <p:to x="100000" y="60000"/>
-                                    </p:animScale>
-                                    <p:animScale>
-                                      <p:cBhvr>
-                                        <p:cTn id="32" dur="166" decel="50000">
-                                          <p:stCondLst>
-                                            <p:cond delay="676"/>
-                                          </p:stCondLst>
-                                        </p:cTn>
-                                        <p:tgtEl>
-                                          <p:spTgt spid="3">
-                                            <p:txEl>
-                                              <p:pRg st="2" end="2"/>
-                                            </p:txEl>
-                                          </p:spTgt>
-                                        </p:tgtEl>
-                                      </p:cBhvr>
-                                      <p:to x="100000" y="100000"/>
-                                    </p:animScale>
-                                    <p:animScale>
-                                      <p:cBhvr>
-                                        <p:cTn id="33" dur="26">
-                                          <p:stCondLst>
-                                            <p:cond delay="1312"/>
-                                          </p:stCondLst>
-                                        </p:cTn>
-                                        <p:tgtEl>
-                                          <p:spTgt spid="3">
-                                            <p:txEl>
-                                              <p:pRg st="2" end="2"/>
-                                            </p:txEl>
-                                          </p:spTgt>
-                                        </p:tgtEl>
-                                      </p:cBhvr>
-                                      <p:to x="100000" y="80000"/>
-                                    </p:animScale>
-                                    <p:animScale>
-                                      <p:cBhvr>
-                                        <p:cTn id="34" dur="166" decel="50000">
-                                          <p:stCondLst>
-                                            <p:cond delay="1338"/>
-                                          </p:stCondLst>
-                                        </p:cTn>
-                                        <p:tgtEl>
-                                          <p:spTgt spid="3">
-                                            <p:txEl>
-                                              <p:pRg st="2" end="2"/>
-                                            </p:txEl>
-                                          </p:spTgt>
-                                        </p:tgtEl>
-                                      </p:cBhvr>
-                                      <p:to x="100000" y="100000"/>
-                                    </p:animScale>
-                                    <p:animScale>
-                                      <p:cBhvr>
-                                        <p:cTn id="35" dur="26">
-                                          <p:stCondLst>
-                                            <p:cond delay="1642"/>
-                                          </p:stCondLst>
-                                        </p:cTn>
-                                        <p:tgtEl>
-                                          <p:spTgt spid="3">
-                                            <p:txEl>
-                                              <p:pRg st="2" end="2"/>
-                                            </p:txEl>
-                                          </p:spTgt>
-                                        </p:tgtEl>
-                                      </p:cBhvr>
-                                      <p:to x="100000" y="90000"/>
-                                    </p:animScale>
-                                    <p:animScale>
-                                      <p:cBhvr>
-                                        <p:cTn id="36" dur="166" decel="50000">
-                                          <p:stCondLst>
-                                            <p:cond delay="1668"/>
-                                          </p:stCondLst>
-                                        </p:cTn>
-                                        <p:tgtEl>
-                                          <p:spTgt spid="3">
-                                            <p:txEl>
-                                              <p:pRg st="2" end="2"/>
-                                            </p:txEl>
-                                          </p:spTgt>
-                                        </p:tgtEl>
-                                      </p:cBhvr>
-                                      <p:to x="100000" y="100000"/>
-                                    </p:animScale>
-                                    <p:animScale>
-                                      <p:cBhvr>
-                                        <p:cTn id="37" dur="26">
-                                          <p:stCondLst>
-                                            <p:cond delay="1808"/>
-                                          </p:stCondLst>
-                                        </p:cTn>
-                                        <p:tgtEl>
-                                          <p:spTgt spid="3">
-                                            <p:txEl>
-                                              <p:pRg st="2" end="2"/>
-                                            </p:txEl>
-                                          </p:spTgt>
-                                        </p:tgtEl>
-                                      </p:cBhvr>
-                                      <p:to x="100000" y="95000"/>
-                                    </p:animScale>
-                                    <p:animScale>
-                                      <p:cBhvr>
-                                        <p:cTn id="38" dur="166" decel="50000">
-                                          <p:stCondLst>
-                                            <p:cond delay="1834"/>
-                                          </p:stCondLst>
-                                        </p:cTn>
-                                        <p:tgtEl>
-                                          <p:spTgt spid="3">
-                                            <p:txEl>
-                                              <p:pRg st="2" end="2"/>
-                                            </p:txEl>
-                                          </p:spTgt>
-                                        </p:tgtEl>
-                                      </p:cBhvr>
-                                      <p:to x="100000" y="100000"/>
-                                    </p:animScale>
-                                  </p:childTnLst>
-                                </p:cTn>
-                              </p:par>
-                            </p:childTnLst>
-                          </p:cTn>
-                        </p:par>
-                      </p:childTnLst>
-                    </p:cTn>
-                  </p:par>
-                </p:childTnLst>
-              </p:cTn>
-              <p:prevCondLst>
-                <p:cond evt="onPrev" delay="0">
-                  <p:tgtEl>
-                    <p:sldTgt/>
-                  </p:tgtEl>
-                </p:cond>
-              </p:prevCondLst>
-              <p:nextCondLst>
-                <p:cond evt="onNext" delay="0">
-                  <p:tgtEl>
-                    <p:sldTgt/>
-                  </p:tgtEl>
-                </p:cond>
-              </p:nextCondLst>
-            </p:seq>
-          </p:childTnLst>
-        </p:cTn>
-      </p:par>
-    </p:tnLst>
-  </p:timing>
-</p:sld>
-</file>
-
-<file path=ppt/slides/slide3.xml><?xml version="1.0" encoding="utf-8"?>
-<p:sld xmlns:a="http://schemas.openxmlformats.org/drawingml/2006/main" xmlns:r="http://schemas.openxmlformats.org/officeDocument/2006/relationships" xmlns:p="http://schemas.openxmlformats.org/presentationml/2006/main">
-  <p:cSld>
-    <p:spTree>
-      <p:nvGrpSpPr>
-        <p:cNvPr id="1" name=""/>
-        <p:cNvGrpSpPr/>
-        <p:nvPr/>
-      </p:nvGrpSpPr>
-      <p:grpSpPr>
-        <a:xfrm>
-          <a:off x="0" y="0"/>
-          <a:ext cx="0" cy="0"/>
-          <a:chOff x="0" y="0"/>
-          <a:chExt cx="0" cy="0"/>
-        </a:xfrm>
-      </p:grpSpPr>
-      <p:sp>
-        <p:nvSpPr>
-          <p:cNvPr id="2" name="Заголовок 1">
-            <a:extLst>
-              <a:ext uri="{FF2B5EF4-FFF2-40B4-BE49-F238E27FC236}">
-                <a16:creationId xmlns:a16="http://schemas.microsoft.com/office/drawing/2014/main" id="{2D682F0D-B671-47AB-A018-05458D71A1E4}"/>
-              </a:ext>
-            </a:extLst>
-          </p:cNvPr>
-          <p:cNvSpPr>
-            <a:spLocks noGrp="1"/>
-          </p:cNvSpPr>
-          <p:nvPr>
-            <p:ph type="title"/>
-          </p:nvPr>
-        </p:nvSpPr>
-        <p:spPr/>
-        <p:txBody>
-          <a:bodyPr/>
-          <a:lstStyle/>
-          <a:p>
-            <a:r>
-              <a:rPr lang="ru-RU" b="1" dirty="0">
-                <a:latin typeface="Sitka Subheading" panose="02000505000000020004" pitchFamily="2" charset="0"/>
-              </a:rPr>
-              <a:t>Описание проекта:</a:t>
-            </a:r>
-          </a:p>
-        </p:txBody>
-      </p:sp>
-      <p:sp>
-        <p:nvSpPr>
-          <p:cNvPr id="3" name="Объект 2">
-            <a:extLst>
-              <a:ext uri="{FF2B5EF4-FFF2-40B4-BE49-F238E27FC236}">
-                <a16:creationId xmlns:a16="http://schemas.microsoft.com/office/drawing/2014/main" id="{21CD470F-3CE0-4D4F-9002-F74B6FC7DCDE}"/>
-              </a:ext>
-            </a:extLst>
-          </p:cNvPr>
-          <p:cNvSpPr>
-            <a:spLocks noGrp="1"/>
-          </p:cNvSpPr>
-          <p:nvPr>
-            <p:ph idx="1"/>
-          </p:nvPr>
-        </p:nvSpPr>
-        <p:spPr/>
-        <p:txBody>
-          <a:bodyPr/>
-          <a:lstStyle/>
-          <a:p>
-            <a:pPr marL="0" indent="0">
-              <a:buNone/>
-            </a:pPr>
-            <a:r>
-              <a:rPr lang="ru-RU" dirty="0">
-                <a:latin typeface="Sitka Subheading" panose="02000505000000020004" pitchFamily="2" charset="0"/>
-              </a:rPr>
-              <a:t>Мы с нашей командой решили создать такое </a:t>
-            </a:r>
-            <a:r>
-              <a:rPr lang="ru-RU" dirty="0">
-                <a:solidFill>
-                  <a:srgbClr val="FF0000"/>
-                </a:solidFill>
-                <a:latin typeface="Sitka Subheading" panose="02000505000000020004" pitchFamily="2" charset="0"/>
-              </a:rPr>
-              <a:t>приложение</a:t>
-            </a:r>
-            <a:r>
-              <a:rPr lang="ru-RU" dirty="0">
-                <a:latin typeface="Sitka Subheading" panose="02000505000000020004" pitchFamily="2" charset="0"/>
-              </a:rPr>
-              <a:t>, которое </a:t>
-            </a:r>
-            <a:r>
-              <a:rPr lang="ru-RU" dirty="0">
-                <a:solidFill>
-                  <a:srgbClr val="FF0000"/>
-                </a:solidFill>
-                <a:latin typeface="Sitka Subheading" panose="02000505000000020004" pitchFamily="2" charset="0"/>
-              </a:rPr>
-              <a:t>помогает</a:t>
-            </a:r>
-            <a:r>
-              <a:rPr lang="ru-RU" dirty="0">
-                <a:latin typeface="Sitka Subheading" panose="02000505000000020004" pitchFamily="2" charset="0"/>
-              </a:rPr>
-              <a:t> педагогам, нуждающимся в быстром создании грамот, сертификатов и дипломов, которое </a:t>
-            </a:r>
-            <a:r>
-              <a:rPr lang="ru-RU" dirty="0">
-                <a:solidFill>
-                  <a:srgbClr val="FF0000"/>
-                </a:solidFill>
-                <a:latin typeface="Sitka Subheading" panose="02000505000000020004" pitchFamily="2" charset="0"/>
-              </a:rPr>
-              <a:t>создает</a:t>
-            </a:r>
-            <a:r>
-              <a:rPr lang="ru-RU" dirty="0">
-                <a:latin typeface="Sitka Subheading" panose="02000505000000020004" pitchFamily="2" charset="0"/>
-              </a:rPr>
-              <a:t> эти документы буквально </a:t>
-            </a:r>
-            <a:r>
-              <a:rPr lang="ru-RU" dirty="0">
-                <a:solidFill>
-                  <a:srgbClr val="FF0000"/>
-                </a:solidFill>
-                <a:latin typeface="Sitka Subheading" panose="02000505000000020004" pitchFamily="2" charset="0"/>
-              </a:rPr>
-              <a:t>за несколько минут</a:t>
-            </a:r>
-            <a:r>
-              <a:rPr lang="ru-RU" dirty="0">
-                <a:latin typeface="Sitka Subheading" panose="02000505000000020004" pitchFamily="2" charset="0"/>
-              </a:rPr>
-              <a:t> вместо нескольких часов.</a:t>
-            </a:r>
-          </a:p>
-        </p:txBody>
-      </p:sp>
-    </p:spTree>
-    <p:extLst>
-      <p:ext uri="{BB962C8B-B14F-4D97-AF65-F5344CB8AC3E}">
-        <p14:creationId xmlns:p14="http://schemas.microsoft.com/office/powerpoint/2010/main" val="868632446"/>
-      </p:ext>
-    </p:extLst>
-  </p:cSld>
-  <p:clrMapOvr>
-    <a:masterClrMapping/>
-  </p:clrMapOvr>
-  <p:timing>
-    <p:tnLst>
-      <p:par>
-        <p:cTn id="1" dur="indefinite" restart="never" nodeType="tmRoot">
-          <p:childTnLst>
-            <p:seq concurrent="1" nextAc="seek">
-              <p:cTn id="2" dur="indefinite" nodeType="mainSeq">
-                <p:childTnLst>
-                  <p:par>
-                    <p:cTn id="3" fill="hold">
-                      <p:stCondLst>
-                        <p:cond delay="indefinite"/>
-                      </p:stCondLst>
-                      <p:childTnLst>
-                        <p:par>
-                          <p:cTn id="4" fill="hold">
-                            <p:stCondLst>
-                              <p:cond delay="0"/>
-                            </p:stCondLst>
-                            <p:childTnLst>
-                              <p:par>
-                                <p:cTn id="5" presetID="16" presetClass="entr" presetSubtype="21" fill="hold" nodeType="clickEffect">
-                                  <p:stCondLst>
-                                    <p:cond delay="0"/>
-                                  </p:stCondLst>
-                                  <p:childTnLst>
-                                    <p:set>
-                                      <p:cBhvr>
-                                        <p:cTn id="6" dur="1" fill="hold">
-                                          <p:stCondLst>
-                                            <p:cond delay="0"/>
-                                          </p:stCondLst>
-                                        </p:cTn>
-                                        <p:tgtEl>
-                                          <p:spTgt spid="3">
-                                            <p:txEl>
-                                              <p:pRg st="0" end="0"/>
-                                            </p:txEl>
-                                          </p:spTgt>
-                                        </p:tgtEl>
-                                        <p:attrNameLst>
-                                          <p:attrName>style.visibility</p:attrName>
-                                        </p:attrNameLst>
-                                      </p:cBhvr>
-                                      <p:to>
-                                        <p:strVal val="visible"/>
-                                      </p:to>
-                                    </p:set>
-                                    <p:animEffect transition="in" filter="barn(inVertical)">
-                                      <p:cBhvr>
-                                        <p:cTn id="7" dur="500"/>
-                                        <p:tgtEl>
-                                          <p:spTgt spid="3">
-                                            <p:txEl>
-                                              <p:pRg st="0" end="0"/>
-                                            </p:txEl>
-                                          </p:spTgt>
-                                        </p:tgtEl>
-                                      </p:cBhvr>
-                                    </p:animEffect>
-                                  </p:childTnLst>
-                                </p:cTn>
-                              </p:par>
-                            </p:childTnLst>
-                          </p:cTn>
-                        </p:par>
-                      </p:childTnLst>
-                    </p:cTn>
-                  </p:par>
-                </p:childTnLst>
-              </p:cTn>
-              <p:prevCondLst>
-                <p:cond evt="onPrev" delay="0">
-                  <p:tgtEl>
-                    <p:sldTgt/>
-                  </p:tgtEl>
-                </p:cond>
-              </p:prevCondLst>
-              <p:nextCondLst>
-                <p:cond evt="onNext" delay="0">
-                  <p:tgtEl>
-                    <p:sldTgt/>
-                  </p:tgtEl>
-                </p:cond>
-              </p:nextCondLst>
-            </p:seq>
-          </p:childTnLst>
-        </p:cTn>
-      </p:par>
-    </p:tnLst>
-  </p:timing>
-</p:sld>
-</file>
-
-<file path=ppt/slides/slide4.xml><?xml version="1.0" encoding="utf-8"?>
-<p:sld xmlns:a="http://schemas.openxmlformats.org/drawingml/2006/main" xmlns:r="http://schemas.openxmlformats.org/officeDocument/2006/relationships" xmlns:p="http://schemas.openxmlformats.org/presentationml/2006/main">
-  <p:cSld>
-    <p:spTree>
-      <p:nvGrpSpPr>
-        <p:cNvPr id="1" name=""/>
-        <p:cNvGrpSpPr/>
-        <p:nvPr/>
-      </p:nvGrpSpPr>
-      <p:grpSpPr>
-        <a:xfrm>
-          <a:off x="0" y="0"/>
-          <a:ext cx="0" cy="0"/>
-          <a:chOff x="0" y="0"/>
-          <a:chExt cx="0" cy="0"/>
-        </a:xfrm>
-      </p:grpSpPr>
-      <p:sp>
-        <p:nvSpPr>
-          <p:cNvPr id="2" name="Заголовок 1">
-            <a:extLst>
-              <a:ext uri="{FF2B5EF4-FFF2-40B4-BE49-F238E27FC236}">
-                <a16:creationId xmlns:a16="http://schemas.microsoft.com/office/drawing/2014/main" id="{F69A5382-0611-4E30-AB9F-827ABFA18529}"/>
-              </a:ext>
-            </a:extLst>
-          </p:cNvPr>
-          <p:cNvSpPr>
-            <a:spLocks noGrp="1"/>
-          </p:cNvSpPr>
-          <p:nvPr>
-            <p:ph type="title"/>
-          </p:nvPr>
-        </p:nvSpPr>
-        <p:spPr/>
-        <p:txBody>
-          <a:bodyPr/>
-          <a:lstStyle/>
-          <a:p>
-            <a:r>
-              <a:rPr lang="ru-RU" b="1" dirty="0">
-                <a:latin typeface="Sitka Subheading" panose="02000505000000020004" pitchFamily="2" charset="0"/>
-              </a:rPr>
-              <a:t>Заключение:</a:t>
-            </a:r>
-          </a:p>
-        </p:txBody>
-      </p:sp>
-      <p:sp>
-        <p:nvSpPr>
-          <p:cNvPr id="3" name="Объект 2">
-            <a:extLst>
-              <a:ext uri="{FF2B5EF4-FFF2-40B4-BE49-F238E27FC236}">
-                <a16:creationId xmlns:a16="http://schemas.microsoft.com/office/drawing/2014/main" id="{EFB44DDE-32B0-439C-9AC5-F30F11051BD1}"/>
-              </a:ext>
-            </a:extLst>
-          </p:cNvPr>
-          <p:cNvSpPr>
-            <a:spLocks noGrp="1"/>
-          </p:cNvSpPr>
-          <p:nvPr>
-            <p:ph idx="1"/>
-          </p:nvPr>
-        </p:nvSpPr>
-        <p:spPr/>
-        <p:txBody>
-          <a:bodyPr/>
-          <a:lstStyle/>
-          <a:p>
-            <a:pPr marL="0" indent="0">
-              <a:buNone/>
-            </a:pPr>
-            <a:r>
-              <a:rPr lang="ru-RU" dirty="0"/>
-              <a:t>…</a:t>
-            </a:r>
-          </a:p>
-        </p:txBody>
-      </p:sp>
-    </p:spTree>
-    <p:extLst>
-      <p:ext uri="{BB962C8B-B14F-4D97-AF65-F5344CB8AC3E}">
-        <p14:creationId xmlns:p14="http://schemas.microsoft.com/office/powerpoint/2010/main" val="2345060926"/>
-      </p:ext>
-    </p:extLst>
-  </p:cSld>
-  <p:clrMapOvr>
-    <a:masterClrMapping/>
-  </p:clrMapOvr>
 </p:sld>
 </file>
 

</xml_diff>